<commit_message>
Use real model run in slides; add guide and run outputs
</commit_message>
<xml_diff>
--- a/slides/Break-My-API.pptx
+++ b/slides/Break-My-API.pptx
@@ -1299,7 +1299,7 @@
           <a:p>
             <a:r>
               <a:rPr lang="en-US" dirty="0"/>
-              <a:t>REPLACE these numbers with your real ai/generate.py run before presenting. Never cut this slide.</a:t>
+              <a:t>Real run numbers (ai/run_prompt2.json, ai/run_prompt3.json). Say: five red, three real, two confidently wrong, zero on the expensive bug. Never cut this slide.</a:t>
             </a:r>
             <a:endParaRPr lang="en-US" dirty="0"/>
           </a:p>
@@ -1915,7 +1915,7 @@
           <a:p>
             <a:r>
               <a:rPr lang="en-US" dirty="0"/>
-              <a:t>06:00-09:00. Generate live only if it took under ~40 s in rehearsal; otherwise open ai/generated_cases.json and say it was generated last night with the same prompt.</a:t>
+              <a:t>06:00-08:00. Do NOT generate live (qwen2.5-coder:7b took 91 s). Say: I ran this prompt last night on a local 7B model; this is the unedited output. 9 cases came back, 1 was rejected as malformed (it put a raw token in the auth field).</a:t>
             </a:r>
             <a:endParaRPr lang="en-US" dirty="0"/>
           </a:p>
@@ -2003,7 +2003,7 @@
           <a:p>
             <a:r>
               <a:rPr lang="en-US" dirty="0"/>
-              <a:t>09:00-14:00. Every case starts from a freshly reset database, so re-running one case gives the same verdict. Point at the 'Candidate defects - a human still has to triage these' footer.</a:t>
+              <a:t>08:00-13:00. 8 cases, 5 red. Walk the 3 real bugs first, then the 2 false alarms: they are the most credible moment of the talk. Point at the 'Candidate defects - a human still has to triage these' footer.</a:t>
             </a:r>
             <a:endParaRPr lang="en-US" dirty="0"/>
           </a:p>
@@ -4856,7 +4856,7 @@
                 <a:ea typeface="Arial" pitchFamily="34" charset="-122"/>
                 <a:cs typeface="Arial" pitchFamily="34" charset="-120"/>
               </a:rPr>
-              <a:t>16</a:t>
+              <a:t>8</a:t>
             </a:r>
             <a:endParaRPr lang="en-US" sz="8800" dirty="0"/>
           </a:p>
@@ -4895,7 +4895,7 @@
                 <a:ea typeface="Arial" pitchFamily="34" charset="-122"/>
                 <a:cs typeface="Arial" pitchFamily="34" charset="-120"/>
               </a:rPr>
-              <a:t>hypotheses</a:t>
+              <a:t>cases executed</a:t>
             </a:r>
             <a:endParaRPr lang="en-US" sz="1800" dirty="0"/>
           </a:p>
@@ -4961,7 +4961,7 @@
                 <a:ea typeface="Arial" pitchFamily="34" charset="-122"/>
                 <a:cs typeface="Arial" pitchFamily="34" charset="-120"/>
               </a:rPr>
-              <a:t>10</a:t>
+              <a:t>5</a:t>
             </a:r>
             <a:endParaRPr lang="en-US" sz="8800" dirty="0"/>
           </a:p>
@@ -5060,13 +5060,13 @@
             <a:r>
               <a:rPr lang="en-US" sz="8800" b="1" dirty="0">
                 <a:solidFill>
-                  <a:srgbClr val="1C1F26"/>
+                  <a:srgbClr val="30A46C"/>
                 </a:solidFill>
                 <a:latin typeface="Arial" pitchFamily="34" charset="0"/>
                 <a:ea typeface="Arial" pitchFamily="34" charset="-122"/>
                 <a:cs typeface="Arial" pitchFamily="34" charset="-120"/>
               </a:rPr>
-              <a:t>6</a:t>
+              <a:t>3</a:t>
             </a:r>
             <a:endParaRPr lang="en-US" sz="8800" dirty="0"/>
           </a:p>
@@ -5105,7 +5105,7 @@
                 <a:ea typeface="Arial" pitchFamily="34" charset="-122"/>
                 <a:cs typeface="Arial" pitchFamily="34" charset="-120"/>
               </a:rPr>
-              <a:t>worth filing today</a:t>
+              <a:t>real bugs</a:t>
             </a:r>
             <a:endParaRPr lang="en-US" sz="1800" dirty="0"/>
           </a:p>
@@ -5171,7 +5171,7 @@
                 <a:ea typeface="Arial" pitchFamily="34" charset="-122"/>
                 <a:cs typeface="Arial" pitchFamily="34" charset="-120"/>
               </a:rPr>
-              <a:t>3</a:t>
+              <a:t>2</a:t>
             </a:r>
             <a:endParaRPr lang="en-US" sz="8800" dirty="0"/>
           </a:p>
@@ -5210,7 +5210,7 @@
                 <a:ea typeface="Arial" pitchFamily="34" charset="-122"/>
                 <a:cs typeface="Arial" pitchFamily="34" charset="-120"/>
               </a:rPr>
-              <a:t>not in the case set</a:t>
+              <a:t>false alarms</a:t>
             </a:r>
             <a:endParaRPr lang="en-US" sz="1800" dirty="0"/>
           </a:p>
@@ -5225,7 +5225,7 @@
         <p:spPr>
           <a:xfrm>
             <a:off x="548640" y="4251960"/>
-            <a:ext cx="548640" cy="411480"/>
+            <a:ext cx="1097280" cy="411480"/>
           </a:xfrm>
           <a:prstGeom prst="rect">
             <a:avLst/>
@@ -5249,7 +5249,7 @@
                 <a:ea typeface="Arial" pitchFamily="34" charset="-122"/>
                 <a:cs typeface="Arial" pitchFamily="34" charset="-120"/>
               </a:rPr>
-              <a:t>2</a:t>
+              <a:t>0</a:t>
             </a:r>
             <a:endParaRPr lang="en-US" sz="2400" dirty="0"/>
           </a:p>
@@ -5263,8 +5263,8 @@
         </p:nvSpPr>
         <p:spPr>
           <a:xfrm>
-            <a:off x="1188720" y="4251960"/>
-            <a:ext cx="10058400" cy="411480"/>
+            <a:off x="1737360" y="4251960"/>
+            <a:ext cx="9509760" cy="411480"/>
           </a:xfrm>
           <a:prstGeom prst="rect">
             <a:avLst/>
@@ -5288,7 +5288,7 @@
                 <a:ea typeface="Arial" pitchFamily="34" charset="-122"/>
                 <a:cs typeface="Arial" pitchFamily="34" charset="-120"/>
               </a:rPr>
-              <a:t>real, but arguable (a doc-vs-code mismatch, empty orders)</a:t>
+              <a:t>findings on the money bugs (the business-logic prompt returned 4 near-identical cases)</a:t>
             </a:r>
             <a:endParaRPr lang="en-US" sz="1800" dirty="0"/>
           </a:p>
@@ -5303,7 +5303,7 @@
         <p:spPr>
           <a:xfrm>
             <a:off x="548640" y="4800600"/>
-            <a:ext cx="548640" cy="411480"/>
+            <a:ext cx="1097280" cy="411480"/>
           </a:xfrm>
           <a:prstGeom prst="rect">
             <a:avLst/>
@@ -5327,7 +5327,7 @@
                 <a:ea typeface="Arial" pitchFamily="34" charset="-122"/>
                 <a:cs typeface="Arial" pitchFamily="34" charset="-120"/>
               </a:rPr>
-              <a:t>2</a:t>
+              <a:t>1</a:t>
             </a:r>
             <a:endParaRPr lang="en-US" sz="2400" dirty="0"/>
           </a:p>
@@ -5341,8 +5341,8 @@
         </p:nvSpPr>
         <p:spPr>
           <a:xfrm>
-            <a:off x="1188720" y="4800600"/>
-            <a:ext cx="10058400" cy="411480"/>
+            <a:off x="1737360" y="4800600"/>
+            <a:ext cx="9509760" cy="411480"/>
           </a:xfrm>
           <a:prstGeom prst="rect">
             <a:avLst/>
@@ -5366,7 +5366,7 @@
                 <a:ea typeface="Arial" pitchFamily="34" charset="-122"/>
                 <a:cs typeface="Arial" pitchFamily="34" charset="-120"/>
               </a:rPr>
-              <a:t>guesses that were simply wrong</a:t>
+              <a:t>case rejected as malformed before running</a:t>
             </a:r>
             <a:endParaRPr lang="en-US" sz="1800" dirty="0"/>
           </a:p>
@@ -5381,7 +5381,7 @@
         <p:spPr>
           <a:xfrm>
             <a:off x="548640" y="5349240"/>
-            <a:ext cx="548640" cy="411480"/>
+            <a:ext cx="1097280" cy="411480"/>
           </a:xfrm>
           <a:prstGeom prst="rect">
             <a:avLst/>
@@ -5405,7 +5405,7 @@
                 <a:ea typeface="Arial" pitchFamily="34" charset="-122"/>
                 <a:cs typeface="Arial" pitchFamily="34" charset="-120"/>
               </a:rPr>
-              <a:t>1</a:t>
+              <a:t>91 s</a:t>
             </a:r>
             <a:endParaRPr lang="en-US" sz="2400" dirty="0"/>
           </a:p>
@@ -5419,8 +5419,8 @@
         </p:nvSpPr>
         <p:spPr>
           <a:xfrm>
-            <a:off x="1188720" y="5349240"/>
-            <a:ext cx="10058400" cy="411480"/>
+            <a:off x="1737360" y="5349240"/>
+            <a:ext cx="9509760" cy="411480"/>
           </a:xfrm>
           <a:prstGeom prst="rect">
             <a:avLst/>
@@ -5444,7 +5444,7 @@
                 <a:ea typeface="Arial" pitchFamily="34" charset="-122"/>
                 <a:cs typeface="Arial" pitchFamily="34" charset="-120"/>
               </a:rPr>
-              <a:t>green result that hid a real injection</a:t>
+              <a:t>to generate on a laptop: too slow to run live</a:t>
             </a:r>
             <a:endParaRPr lang="en-US" sz="1800" dirty="0"/>
           </a:p>
@@ -5483,7 +5483,7 @@
                 <a:ea typeface="Courier New" pitchFamily="34" charset="-122"/>
                 <a:cs typeface="Courier New" pitchFamily="34" charset="-120"/>
               </a:rPr>
-              <a:t>One prompt · one small API · saved case set</a:t>
+              <a:t>qwen2.5-coder:7b · local · one prompt · unedited output · 17 Sep 2026</a:t>
             </a:r>
             <a:endParaRPr lang="en-US" sz="1200" dirty="0"/>
           </a:p>
@@ -11192,7 +11192,7 @@
                 <a:ea typeface="Arial" pitchFamily="34" charset="-122"/>
                 <a:cs typeface="Arial" pitchFamily="34" charset="-120"/>
               </a:rPr>
-              <a:t>Generate the attack</a:t>
+              <a:t>What the model wrote</a:t>
             </a:r>
             <a:endParaRPr lang="en-US" sz="4800" dirty="0"/>
           </a:p>
@@ -11272,7 +11272,7 @@
                 <a:ea typeface="Courier New" pitchFamily="34" charset="-122"/>
                 <a:cs typeface="Courier New" pitchFamily="34" charset="-120"/>
               </a:rPr>
-              <a:t>python ai/generate.py --prompt 2</a:t>
+              <a:t>python -m json.tool ai/run_prompt2.json | head -40</a:t>
             </a:r>
             <a:endParaRPr lang="en-US" sz="2400" dirty="0"/>
           </a:p>
@@ -11375,7 +11375,7 @@
                 <a:ea typeface="Arial" pitchFamily="34" charset="-122"/>
                 <a:cs typeface="Arial" pitchFamily="34" charset="-120"/>
               </a:rPr>
-              <a:t>The five assumptions it thinks the API makes</a:t>
+              <a:t>Its five assumptions: valid tokens, permissions, clean input, ranges, use-once state</a:t>
             </a:r>
             <a:endParaRPr lang="en-US" sz="2000" dirty="0"/>
           </a:p>
@@ -11439,7 +11439,7 @@
                 <a:ea typeface="Arial" pitchFamily="34" charset="-122"/>
                 <a:cs typeface="Arial" pitchFamily="34" charset="-120"/>
               </a:rPr>
-              <a:t>One full case: payload, auth, and what a correct API should return</a:t>
+              <a:t>One full case: auth, payload, and what it says a correct API returns</a:t>
             </a:r>
             <a:endParaRPr lang="en-US" sz="2000" dirty="0"/>
           </a:p>
@@ -11503,7 +11503,7 @@
                 <a:ea typeface="Arial" pitchFamily="34" charset="-122"/>
                 <a:cs typeface="Arial" pitchFamily="34" charset="-120"/>
               </a:rPr>
-              <a:t>Don't read every case. Under three minutes.</a:t>
+              <a:t>Generated last night: 91 seconds on a laptop, output unedited</a:t>
             </a:r>
             <a:endParaRPr lang="en-US" sz="2000" dirty="0"/>
           </a:p>
@@ -11693,7 +11693,7 @@
                 <a:ea typeface="Courier New" pitchFamily="34" charset="-122"/>
                 <a:cs typeface="Courier New" pitchFamily="34" charset="-120"/>
               </a:rPr>
-              <a:t>python -m tests.runner</a:t>
+              <a:t>python -m tests.runner --cases ai/run_prompt2.json</a:t>
             </a:r>
             <a:endParaRPr lang="en-US" sz="2400" dirty="0"/>
           </a:p>
@@ -11796,7 +11796,7 @@
                 <a:ea typeface="Arial" pitchFamily="34" charset="-122"/>
                 <a:cs typeface="Arial" pitchFamily="34" charset="-120"/>
               </a:rPr>
-              <a:t>TC-001: minus five tickets, 201 Created, negative charge</a:t>
+              <a:t>Real bugs: TC-002 bad token → 500 · TC-004 forged admin · TC-005 IDOR</a:t>
             </a:r>
             <a:endParaRPr lang="en-US" sz="2000" dirty="0"/>
           </a:p>
@@ -11860,7 +11860,7 @@
                 <a:ea typeface="Arial" pitchFamily="34" charset="-122"/>
                 <a:cs typeface="Arial" pitchFamily="34" charset="-120"/>
               </a:rPr>
-              <a:t>TC-011: a token I made up returns role: admin</a:t>
+              <a:t>False alarm: TC-006 expects a 500 as the correct answer to SQL injection</a:t>
             </a:r>
             <a:endParaRPr lang="en-US" sz="2000" dirty="0"/>
           </a:p>
@@ -11924,7 +11924,7 @@
                 <a:ea typeface="Arial" pitchFamily="34" charset="-122"/>
                 <a:cs typeface="Arial" pitchFamily="34" charset="-120"/>
               </a:rPr>
-              <a:t>TC-006 green, TC-007 red: same idea, one payload lied</a:t>
+              <a:t>False alarm: TC-009 treats the unlimited EARLYBIRD coupon as single-use</a:t>
             </a:r>
             <a:endParaRPr lang="en-US" sz="2000" dirty="0"/>
           </a:p>

</xml_diff>

<commit_message>
Slide 12: use real-run false alarms
</commit_message>
<xml_diff>
--- a/slides/Break-My-API.pptx
+++ b/slides/Break-My-API.pptx
@@ -1123,7 +1123,7 @@
           <a:p>
             <a:r>
               <a:rPr lang="en-US" dirty="0"/>
-              <a:t>Be precise: many models will suggest testing concurrency or the student ticket. The claim is that it couldn't run the race in this format, and couldn't know the pricing rule. Don't say 'AI can't find these'.</a:t>
+              <a:t>From the real qwen2.5-coder:7b run. Race: the case format can't express concurrency. False alarms: TC-006 and TC-009 from ai/run_prompt2.json. Student rule: not in the repo. Be precise: say 'this model, this format, this context', never 'AI can't'.</a:t>
             </a:r>
             <a:endParaRPr lang="en-US" dirty="0"/>
           </a:p>
@@ -4033,7 +4033,7 @@
         <p:spPr>
           <a:xfrm>
             <a:off x="4654296" y="1828800"/>
-            <a:ext cx="1330452" cy="329184"/>
+            <a:ext cx="1714500" cy="329184"/>
           </a:xfrm>
           <a:prstGeom prst="roundRect">
             <a:avLst>
@@ -4060,7 +4060,7 @@
         <p:spPr>
           <a:xfrm>
             <a:off x="4654296" y="1828800"/>
-            <a:ext cx="1330452" cy="329184"/>
+            <a:ext cx="1714500" cy="329184"/>
           </a:xfrm>
           <a:prstGeom prst="rect">
             <a:avLst/>
@@ -4084,7 +4084,7 @@
                 <a:ea typeface="Courier New" pitchFamily="34" charset="-122"/>
                 <a:cs typeface="Courier New" pitchFamily="34" charset="-120"/>
               </a:rPr>
-              <a:t>STUDENT 201</a:t>
+              <a:t>TC-006 · TC-009</a:t>
             </a:r>
             <a:endParaRPr lang="en-US" sz="1200" dirty="0"/>
           </a:p>
@@ -4123,7 +4123,7 @@
                 <a:ea typeface="Arial" pitchFamily="34" charset="-122"/>
                 <a:cs typeface="Arial" pitchFamily="34" charset="-120"/>
               </a:rPr>
-              <a:t>It couldn't know it</a:t>
+              <a:t>Confidently wrong</a:t>
             </a:r>
             <a:endParaRPr lang="en-US" sz="2100" dirty="0"/>
           </a:p>
@@ -4162,7 +4162,7 @@
                 <a:ea typeface="Arial" pitchFamily="34" charset="-122"/>
                 <a:cs typeface="Arial" pitchFamily="34" charset="-120"/>
               </a:rPr>
-              <a:t>Student pricing needs a verified student address. That rule lives in a policy doc, so nobody reading the repo can confirm the 201 is wrong.</a:t>
+              <a:t>It called a 500 the correct answer to SQL injection, and treated the unlimited EARLYBIRD coupon as single-use. Both went red. Neither was a bug.</a:t>
             </a:r>
             <a:endParaRPr lang="en-US" sz="1600" dirty="0"/>
           </a:p>
@@ -4212,11 +4212,11 @@
             </a:avLst>
           </a:prstGeom>
           <a:solidFill>
-            <a:srgbClr val="30A46C"/>
+            <a:srgbClr val="E5484D"/>
           </a:solidFill>
           <a:ln w="12700">
             <a:solidFill>
-              <a:srgbClr val="30A46C"/>
+              <a:srgbClr val="E5484D"/>
             </a:solidFill>
             <a:prstDash val="solid"/>
           </a:ln>
@@ -4255,7 +4255,7 @@
                 <a:ea typeface="Courier New" pitchFamily="34" charset="-122"/>
                 <a:cs typeface="Courier New" pitchFamily="34" charset="-120"/>
               </a:rPr>
-              <a:t>TC-006 PASS</a:t>
+              <a:t>STUDENT 201</a:t>
             </a:r>
             <a:endParaRPr lang="en-US" sz="1200" dirty="0"/>
           </a:p>
@@ -4294,7 +4294,7 @@
                 <a:ea typeface="Arial" pitchFamily="34" charset="-122"/>
                 <a:cs typeface="Arial" pitchFamily="34" charset="-120"/>
               </a:rPr>
-              <a:t>Green isn't proof</a:t>
+              <a:t>It couldn't know it</a:t>
             </a:r>
             <a:endParaRPr lang="en-US" sz="2100" dirty="0"/>
           </a:p>
@@ -4333,7 +4333,7 @@
                 <a:ea typeface="Arial" pitchFamily="34" charset="-122"/>
                 <a:cs typeface="Arial" pitchFamily="34" charset="-120"/>
               </a:rPr>
-              <a:t>Same injection idea, two payloads. One passed, one leaked a hidden ticket. A pass only means that guess wasn't confirmed.</a:t>
+              <a:t>Student pricing needs a verified student address. That rule lives in a policy doc, so nobody reading the repo can confirm the 201 is wrong.</a:t>
             </a:r>
             <a:endParaRPr lang="en-US" sz="1600" dirty="0"/>
           </a:p>
@@ -4372,7 +4372,7 @@
                 <a:ea typeface="Arial" pitchFamily="34" charset="-122"/>
                 <a:cs typeface="Arial" pitchFamily="34" charset="-120"/>
               </a:rPr>
-              <a:t>Want these found? Give the harness a way to say "run these together", and write the rules where a reader can find them.</a:t>
+              <a:t>Triage every red line, give the harness a way to say "run these together", and write the rules where a reader can find them.</a:t>
             </a:r>
             <a:endParaRPr lang="en-US" sz="1800" dirty="0"/>
           </a:p>

</xml_diff>

<commit_message>
Add event theme line to opening slide
</commit_message>
<xml_diff>
--- a/slides/Break-My-API.pptx
+++ b/slides/Break-My-API.pptx
@@ -527,7 +527,7 @@
           <a:p>
             <a:r>
               <a:rPr lang="en-US" dirty="0"/>
-              <a:t>Keep this short. Terminal is ready behind the slides with the API running.</a:t>
+              <a:t>Opening: Today's theme is 'beyond the prompt'. My talk is a small, real example: the prompt got AI to suggest attacks, but it was the engineering around it, running every idea and checking the evidence, that told me which ones were true. Keep this short; the terminal is ready behind the slides with the API running.</a:t>
             </a:r>
             <a:endParaRPr lang="en-US" dirty="0"/>
           </a:p>
@@ -3429,6 +3429,59 @@
         </p:nvSpPr>
         <p:spPr>
           <a:xfrm>
+            <a:off x="548640" y="4389120"/>
+            <a:ext cx="8229600" cy="731520"/>
+          </a:xfrm>
+          <a:prstGeom prst="rect">
+            <a:avLst/>
+          </a:prstGeom>
+          <a:noFill/>
+          <a:ln/>
+        </p:spPr>
+        <p:txBody>
+          <a:bodyPr wrap="square" lIns="0" tIns="0" rIns="0" bIns="0" rtlCol="0" anchor="t"/>
+          <a:lstStyle/>
+          <a:p>
+            <a:pPr indent="0" marL="0">
+              <a:buNone/>
+            </a:pPr>
+            <a:r>
+              <a:rPr lang="en-US" sz="1700" b="1" dirty="0">
+                <a:solidFill>
+                  <a:srgbClr val="EDEFF4"/>
+                </a:solidFill>
+                <a:latin typeface="Arial" pitchFamily="34" charset="0"/>
+                <a:ea typeface="Arial" pitchFamily="34" charset="-122"/>
+                <a:cs typeface="Arial" pitchFamily="34" charset="-120"/>
+              </a:rPr>
+              <a:t>Beyond the prompt: </a:t>
+            </a:r>
+            <a:pPr indent="0" marL="0">
+              <a:buNone/>
+            </a:pPr>
+            <a:r>
+              <a:rPr lang="en-US" sz="1700" dirty="0">
+                <a:solidFill>
+                  <a:srgbClr val="A3AABB"/>
+                </a:solidFill>
+                <a:latin typeface="Arial" pitchFamily="34" charset="0"/>
+                <a:ea typeface="Arial" pitchFamily="34" charset="-122"/>
+                <a:cs typeface="Arial" pitchFamily="34" charset="-120"/>
+              </a:rPr>
+              <a:t>AI suggests the attacks. Running them and checking the evidence tells us which are real.</a:t>
+            </a:r>
+            <a:endParaRPr lang="en-US" sz="1700" dirty="0"/>
+          </a:p>
+        </p:txBody>
+      </p:sp>
+      <p:sp>
+        <p:nvSpPr>
+          <p:cNvPr id="13" name="Text 8"/>
+          <p:cNvSpPr txBox="1"/>
+          <p:nvPr/>
+        </p:nvSpPr>
+        <p:spPr>
+          <a:xfrm>
             <a:off x="548640" y="5212080"/>
             <a:ext cx="6400800" cy="457200"/>
           </a:xfrm>
@@ -3462,7 +3515,7 @@
       </p:sp>
       <p:sp>
         <p:nvSpPr>
-          <p:cNvPr id="13" name="Text 8"/>
+          <p:cNvPr id="14" name="Text 9"/>
           <p:cNvSpPr txBox="1"/>
           <p:nvPr/>
         </p:nvSpPr>
@@ -3501,7 +3554,7 @@
       </p:sp>
       <p:sp>
         <p:nvSpPr>
-          <p:cNvPr id="14" name="Text 9"/>
+          <p:cNvPr id="15" name="Text 10"/>
           <p:cNvSpPr txBox="1"/>
           <p:nvPr/>
         </p:nvSpPr>

</xml_diff>